<commit_message>
fix(01): follow the slide order in the demo and pin ruff 0.15.22
- Pin ruff to 0.15.22: PLR1730 joined the default rules in 0.16.0, so
  `ruff check --isolated` no longer said "All checks passed!" (slide 14).
- Run the slip-through bug and the boundary case on before/, as the
  slides do, then check after/ against the 432-case golden master copied
  from before/ instead of regenerating it (which verified nothing).
- after/test_golden_master.py carries the boundary case from the start.
- Fix the slide numbers in the README and the test counts (11 passed).
- Slides 33 and 35: name the test file run, and show 11 passed.
- Restore the stale .pyc note; ignore golden_master.json.

Co-Authored-By: Claude Opus 5.5 <noreply@anthropic.com>
</commit_message>
<xml_diff>
--- a/01_first_ruff_then_we_test/テストコードと静的チェック_講習スライド.pptx
+++ b/01_first_ruff_then_we_test/テストコードと静的チェック_講習スライド.pptx
@@ -2893,7 +2893,7 @@
           <a:p>
             <a:r>
               <a:rPr lang="en-US" dirty="0"/>
-              <a:t>デモ⑦: 実行して 13 passed を見せる。
+              <a:t>デモ⑦: 実行して 11 passed を見せる。
 パラメータ化を知っているだけで、テストを書く手数がかなり減る。</a:t>
             </a:r>
           </a:p>
@@ -22318,7 +22318,7 @@
                 <a:ea typeface="Consolas" pitchFamily="34" charset="-122"/>
                 <a:cs typeface="Consolas" pitchFamily="34" charset="-120"/>
               </a:rPr>
-              <a:t>&gt; ruff check billing.py     →  All checks passed!</a:t>
+              <a:t>&gt; ruff check billing.py              →  All checks passed!</a:t>
             </a:r>
             <a:endParaRPr lang="en-US" sz="1270" dirty="0"/>
           </a:p>
@@ -22338,7 +22338,7 @@
                 <a:ea typeface="Consolas" pitchFamily="34" charset="-122"/>
                 <a:cs typeface="Consolas" pitchFamily="34" charset="-120"/>
               </a:rPr>
-              <a:t>&gt; pytest -q                 →  1 passed, 1 skipped   （432ケース、値は1円も変わっていない）</a:t>
+              <a:t>&gt; pytest -q test_golden_master.py    →  1 passed, 1 skipped   （432ケース、値は1円も変わっていない）</a:t>
             </a:r>
             <a:endParaRPr lang="en-US" sz="1270" dirty="0"/>
           </a:p>
@@ -23549,7 +23549,7 @@
                 <a:ea typeface="Consolas" pitchFamily="34" charset="-122"/>
                 <a:cs typeface="Consolas" pitchFamily="34" charset="-120"/>
               </a:rPr>
-              <a:t>&gt; pytest -q</a:t>
+              <a:t>&gt; pytest -q test_billing.py</a:t>
             </a:r>
             <a:endParaRPr lang="en-US" sz="1270" dirty="0"/>
           </a:p>
@@ -23569,7 +23569,7 @@
                 <a:ea typeface="Consolas" pitchFamily="34" charset="-122"/>
                 <a:cs typeface="Consolas" pitchFamily="34" charset="-120"/>
               </a:rPr>
-              <a:t>.............      [100%]</a:t>
+              <a:t>...........        [100%]</a:t>
             </a:r>
             <a:endParaRPr lang="en-US" sz="1270" dirty="0"/>
           </a:p>
@@ -23589,7 +23589,7 @@
                 <a:ea typeface="Consolas" pitchFamily="34" charset="-122"/>
                 <a:cs typeface="Consolas" pitchFamily="34" charset="-120"/>
               </a:rPr>
-              <a:t>13 passed in 0.02s</a:t>
+              <a:t>11 passed in 0.01s</a:t>
             </a:r>
             <a:endParaRPr lang="en-US" sz="1270" dirty="0"/>
           </a:p>

</xml_diff>